<commit_message>
some stuff i guess
</commit_message>
<xml_diff>
--- a/figs/rheo.pptx
+++ b/figs/rheo.pptx
@@ -260,7 +260,7 @@
           <a:p>
             <a:fld id="{0559B29D-D28E-4B55-A1FF-D0DD23F2421F}" type="datetimeFigureOut">
               <a:rPr lang="en-US" smtClean="0"/>
-              <a:t>4/22/2026</a:t>
+              <a:t>5/5/2026</a:t>
             </a:fld>
             <a:endParaRPr lang="en-US"/>
           </a:p>
@@ -458,7 +458,7 @@
           <a:p>
             <a:fld id="{0559B29D-D28E-4B55-A1FF-D0DD23F2421F}" type="datetimeFigureOut">
               <a:rPr lang="en-US" smtClean="0"/>
-              <a:t>4/22/2026</a:t>
+              <a:t>5/5/2026</a:t>
             </a:fld>
             <a:endParaRPr lang="en-US"/>
           </a:p>
@@ -666,7 +666,7 @@
           <a:p>
             <a:fld id="{0559B29D-D28E-4B55-A1FF-D0DD23F2421F}" type="datetimeFigureOut">
               <a:rPr lang="en-US" smtClean="0"/>
-              <a:t>4/22/2026</a:t>
+              <a:t>5/5/2026</a:t>
             </a:fld>
             <a:endParaRPr lang="en-US"/>
           </a:p>
@@ -864,7 +864,7 @@
           <a:p>
             <a:fld id="{0559B29D-D28E-4B55-A1FF-D0DD23F2421F}" type="datetimeFigureOut">
               <a:rPr lang="en-US" smtClean="0"/>
-              <a:t>4/22/2026</a:t>
+              <a:t>5/5/2026</a:t>
             </a:fld>
             <a:endParaRPr lang="en-US"/>
           </a:p>
@@ -1139,7 +1139,7 @@
           <a:p>
             <a:fld id="{0559B29D-D28E-4B55-A1FF-D0DD23F2421F}" type="datetimeFigureOut">
               <a:rPr lang="en-US" smtClean="0"/>
-              <a:t>4/22/2026</a:t>
+              <a:t>5/5/2026</a:t>
             </a:fld>
             <a:endParaRPr lang="en-US"/>
           </a:p>
@@ -1404,7 +1404,7 @@
           <a:p>
             <a:fld id="{0559B29D-D28E-4B55-A1FF-D0DD23F2421F}" type="datetimeFigureOut">
               <a:rPr lang="en-US" smtClean="0"/>
-              <a:t>4/22/2026</a:t>
+              <a:t>5/5/2026</a:t>
             </a:fld>
             <a:endParaRPr lang="en-US"/>
           </a:p>
@@ -1816,7 +1816,7 @@
           <a:p>
             <a:fld id="{0559B29D-D28E-4B55-A1FF-D0DD23F2421F}" type="datetimeFigureOut">
               <a:rPr lang="en-US" smtClean="0"/>
-              <a:t>4/22/2026</a:t>
+              <a:t>5/5/2026</a:t>
             </a:fld>
             <a:endParaRPr lang="en-US"/>
           </a:p>
@@ -1957,7 +1957,7 @@
           <a:p>
             <a:fld id="{0559B29D-D28E-4B55-A1FF-D0DD23F2421F}" type="datetimeFigureOut">
               <a:rPr lang="en-US" smtClean="0"/>
-              <a:t>4/22/2026</a:t>
+              <a:t>5/5/2026</a:t>
             </a:fld>
             <a:endParaRPr lang="en-US"/>
           </a:p>
@@ -2070,7 +2070,7 @@
           <a:p>
             <a:fld id="{0559B29D-D28E-4B55-A1FF-D0DD23F2421F}" type="datetimeFigureOut">
               <a:rPr lang="en-US" smtClean="0"/>
-              <a:t>4/22/2026</a:t>
+              <a:t>5/5/2026</a:t>
             </a:fld>
             <a:endParaRPr lang="en-US"/>
           </a:p>
@@ -2381,7 +2381,7 @@
           <a:p>
             <a:fld id="{0559B29D-D28E-4B55-A1FF-D0DD23F2421F}" type="datetimeFigureOut">
               <a:rPr lang="en-US" smtClean="0"/>
-              <a:t>4/22/2026</a:t>
+              <a:t>5/5/2026</a:t>
             </a:fld>
             <a:endParaRPr lang="en-US"/>
           </a:p>
@@ -2669,7 +2669,7 @@
           <a:p>
             <a:fld id="{0559B29D-D28E-4B55-A1FF-D0DD23F2421F}" type="datetimeFigureOut">
               <a:rPr lang="en-US" smtClean="0"/>
-              <a:t>4/22/2026</a:t>
+              <a:t>5/5/2026</a:t>
             </a:fld>
             <a:endParaRPr lang="en-US"/>
           </a:p>
@@ -2910,7 +2910,7 @@
           <a:p>
             <a:fld id="{0559B29D-D28E-4B55-A1FF-D0DD23F2421F}" type="datetimeFigureOut">
               <a:rPr lang="en-US" smtClean="0"/>
-              <a:t>4/22/2026</a:t>
+              <a:t>5/5/2026</a:t>
             </a:fld>
             <a:endParaRPr lang="en-US"/>
           </a:p>
@@ -4546,182 +4546,8 @@
           </a:p>
         </p:txBody>
       </p:sp>
-      <mc:AlternateContent xmlns:mc="http://schemas.openxmlformats.org/markup-compatibility/2006" xmlns:a14="http://schemas.microsoft.com/office/drawing/2010/main">
-        <mc:Choice Requires="a14">
-          <p:sp>
-            <p:nvSpPr>
-              <p:cNvPr id="49" name="TextBox 48">
-                <a:extLst>
-                  <a:ext uri="{FF2B5EF4-FFF2-40B4-BE49-F238E27FC236}">
-                    <a16:creationId xmlns:a16="http://schemas.microsoft.com/office/drawing/2014/main" id="{ECEEAC08-5E43-2D79-2194-DB4D82B4E7C6}"/>
-                  </a:ext>
-                </a:extLst>
-              </p:cNvPr>
-              <p:cNvSpPr txBox="1"/>
-              <p:nvPr/>
-            </p:nvSpPr>
-            <p:spPr>
-              <a:xfrm>
-                <a:off x="1645249" y="95094"/>
-                <a:ext cx="6819174" cy="430887"/>
-              </a:xfrm>
-              <a:prstGeom prst="rect">
-                <a:avLst/>
-              </a:prstGeom>
-              <a:noFill/>
-            </p:spPr>
-            <p:txBody>
-              <a:bodyPr wrap="none" lIns="0" tIns="0" rIns="0" bIns="0" rtlCol="0">
-                <a:spAutoFit/>
-              </a:bodyPr>
-              <a:lstStyle/>
-              <a:p>
-                <a:pPr/>
-                <a14:m>
-                  <m:oMathPara xmlns:m="http://schemas.openxmlformats.org/officeDocument/2006/math">
-                    <m:oMathParaPr>
-                      <m:jc m:val="centerGroup"/>
-                    </m:oMathParaPr>
-                    <m:oMath xmlns:m="http://schemas.openxmlformats.org/officeDocument/2006/math">
-                      <m:r>
-                        <m:rPr>
-                          <m:sty m:val="p"/>
-                        </m:rPr>
-                        <a:rPr lang="en-US" sz="2800" b="0" i="1" smtClean="0">
-                          <a:latin typeface="Cambria Math" panose="02040503050406030204" pitchFamily="18" charset="0"/>
-                        </a:rPr>
-                        <m:t>Carreau</m:t>
-                      </m:r>
-                      <m:r>
-                        <a:rPr lang="en-US" sz="2800" b="0" i="1" smtClean="0">
-                          <a:latin typeface="Cambria Math" panose="02040503050406030204" pitchFamily="18" charset="0"/>
-                        </a:rPr>
-                        <m:t> </m:t>
-                      </m:r>
-                      <m:r>
-                        <m:rPr>
-                          <m:sty m:val="p"/>
-                        </m:rPr>
-                        <a:rPr lang="en-US" sz="2800" b="0" i="1" smtClean="0">
-                          <a:latin typeface="Cambria Math" panose="02040503050406030204" pitchFamily="18" charset="0"/>
-                        </a:rPr>
-                        <m:t>Rheology</m:t>
-                      </m:r>
-                      <m:r>
-                        <a:rPr lang="en-US" sz="2800" b="0" i="1" smtClean="0">
-                          <a:latin typeface="Cambria Math" panose="02040503050406030204" pitchFamily="18" charset="0"/>
-                        </a:rPr>
-                        <m:t> </m:t>
-                      </m:r>
-                      <m:r>
-                        <m:rPr>
-                          <m:sty m:val="p"/>
-                        </m:rPr>
-                        <a:rPr lang="en-US" sz="2800" b="0" i="1" smtClean="0">
-                          <a:latin typeface="Cambria Math" panose="02040503050406030204" pitchFamily="18" charset="0"/>
-                        </a:rPr>
-                        <m:t>for</m:t>
-                      </m:r>
-                      <m:r>
-                        <a:rPr lang="en-US" sz="2800" b="0" i="1" smtClean="0">
-                          <a:latin typeface="Cambria Math" panose="02040503050406030204" pitchFamily="18" charset="0"/>
-                        </a:rPr>
-                        <m:t> </m:t>
-                      </m:r>
-                      <m:r>
-                        <m:rPr>
-                          <m:sty m:val="p"/>
-                        </m:rPr>
-                        <a:rPr lang="en-US" sz="2800" b="0" i="1" smtClean="0">
-                          <a:latin typeface="Cambria Math" panose="02040503050406030204" pitchFamily="18" charset="0"/>
-                        </a:rPr>
-                        <m:t>Shear</m:t>
-                      </m:r>
-                      <m:r>
-                        <a:rPr lang="en-US" sz="2800" b="0" i="1" smtClean="0">
-                          <a:latin typeface="Cambria Math" panose="02040503050406030204" pitchFamily="18" charset="0"/>
-                        </a:rPr>
-                        <m:t>−</m:t>
-                      </m:r>
-                      <m:r>
-                        <m:rPr>
-                          <m:sty m:val="p"/>
-                        </m:rPr>
-                        <a:rPr lang="en-US" sz="2800" b="0" i="1" smtClean="0">
-                          <a:latin typeface="Cambria Math" panose="02040503050406030204" pitchFamily="18" charset="0"/>
-                        </a:rPr>
-                        <m:t>Thinning</m:t>
-                      </m:r>
-                      <m:r>
-                        <a:rPr lang="en-US" sz="2800" b="0" i="1" smtClean="0">
-                          <a:latin typeface="Cambria Math" panose="02040503050406030204" pitchFamily="18" charset="0"/>
-                        </a:rPr>
-                        <m:t> </m:t>
-                      </m:r>
-                      <m:r>
-                        <m:rPr>
-                          <m:sty m:val="p"/>
-                        </m:rPr>
-                        <a:rPr lang="en-US" sz="2800" b="0" i="1" smtClean="0">
-                          <a:latin typeface="Cambria Math" panose="02040503050406030204" pitchFamily="18" charset="0"/>
-                        </a:rPr>
-                        <m:t>Fluids</m:t>
-                      </m:r>
-                    </m:oMath>
-                  </m:oMathPara>
-                </a14:m>
-                <a:endParaRPr lang="en-US" sz="2800" dirty="0"/>
-              </a:p>
-            </p:txBody>
-          </p:sp>
-        </mc:Choice>
-        <mc:Fallback xmlns="">
-          <p:sp>
-            <p:nvSpPr>
-              <p:cNvPr id="49" name="TextBox 48">
-                <a:extLst>
-                  <a:ext uri="{FF2B5EF4-FFF2-40B4-BE49-F238E27FC236}">
-                    <a16:creationId xmlns:a16="http://schemas.microsoft.com/office/drawing/2014/main" id="{ECEEAC08-5E43-2D79-2194-DB4D82B4E7C6}"/>
-                  </a:ext>
-                </a:extLst>
-              </p:cNvPr>
-              <p:cNvSpPr txBox="1">
-                <a:spLocks noRot="1" noChangeAspect="1" noMove="1" noResize="1" noEditPoints="1" noAdjustHandles="1" noChangeArrowheads="1" noChangeShapeType="1" noTextEdit="1"/>
-              </p:cNvSpPr>
-              <p:nvPr/>
-            </p:nvSpPr>
-            <p:spPr>
-              <a:xfrm>
-                <a:off x="1645249" y="95094"/>
-                <a:ext cx="6819174" cy="430887"/>
-              </a:xfrm>
-              <a:prstGeom prst="rect">
-                <a:avLst/>
-              </a:prstGeom>
-              <a:blipFill>
-                <a:blip r:embed="rId6"/>
-                <a:stretch>
-                  <a:fillRect/>
-                </a:stretch>
-              </a:blipFill>
-            </p:spPr>
-            <p:txBody>
-              <a:bodyPr/>
-              <a:lstStyle/>
-              <a:p>
-                <a:r>
-                  <a:rPr lang="en-US">
-                    <a:noFill/>
-                  </a:rPr>
-                  <a:t> </a:t>
-                </a:r>
-              </a:p>
-            </p:txBody>
-          </p:sp>
-        </mc:Fallback>
-      </mc:AlternateContent>
-      <mc:AlternateContent xmlns:mc="http://schemas.openxmlformats.org/markup-compatibility/2006" xmlns:a14="http://schemas.microsoft.com/office/drawing/2010/main">
-        <mc:Choice Requires="a14">
+      <mc:AlternateContent xmlns:mc="http://schemas.openxmlformats.org/markup-compatibility/2006">
+        <mc:Choice xmlns:a14="http://schemas.microsoft.com/office/drawing/2010/main" Requires="a14">
           <p:sp>
             <p:nvSpPr>
               <p:cNvPr id="50" name="TextBox 49">
@@ -4736,7 +4562,7 @@
             </p:nvSpPr>
             <p:spPr>
               <a:xfrm>
-                <a:off x="3414046" y="5211616"/>
+                <a:off x="3670418" y="5571969"/>
                 <a:ext cx="1384418" cy="307777"/>
               </a:xfrm>
               <a:prstGeom prst="rect">
@@ -4814,7 +4640,7 @@
             </p:txBody>
           </p:sp>
         </mc:Choice>
-        <mc:Fallback xmlns="">
+        <mc:Fallback>
           <p:sp>
             <p:nvSpPr>
               <p:cNvPr id="50" name="TextBox 49">
@@ -4831,8 +4657,119 @@
             </p:nvSpPr>
             <p:spPr>
               <a:xfrm>
-                <a:off x="3414046" y="5211616"/>
+                <a:off x="3670418" y="5571969"/>
                 <a:ext cx="1384418" cy="307777"/>
+              </a:xfrm>
+              <a:prstGeom prst="rect">
+                <a:avLst/>
+              </a:prstGeom>
+              <a:blipFill>
+                <a:blip r:embed="rId6"/>
+                <a:stretch>
+                  <a:fillRect b="-5882"/>
+                </a:stretch>
+              </a:blipFill>
+            </p:spPr>
+            <p:txBody>
+              <a:bodyPr/>
+              <a:lstStyle/>
+              <a:p>
+                <a:r>
+                  <a:rPr lang="en-US">
+                    <a:noFill/>
+                  </a:rPr>
+                  <a:t> </a:t>
+                </a:r>
+              </a:p>
+            </p:txBody>
+          </p:sp>
+        </mc:Fallback>
+      </mc:AlternateContent>
+      <mc:AlternateContent xmlns:mc="http://schemas.openxmlformats.org/markup-compatibility/2006">
+        <mc:Choice xmlns:a14="http://schemas.microsoft.com/office/drawing/2010/main" Requires="a14">
+          <p:sp>
+            <p:nvSpPr>
+              <p:cNvPr id="2" name="TextBox 1">
+                <a:extLst>
+                  <a:ext uri="{FF2B5EF4-FFF2-40B4-BE49-F238E27FC236}">
+                    <a16:creationId xmlns:a16="http://schemas.microsoft.com/office/drawing/2014/main" id="{1BB98F22-5D62-E6B7-4108-0A58A1E1CDF2}"/>
+                  </a:ext>
+                </a:extLst>
+              </p:cNvPr>
+              <p:cNvSpPr txBox="1"/>
+              <p:nvPr/>
+            </p:nvSpPr>
+            <p:spPr>
+              <a:xfrm>
+                <a:off x="804885" y="458290"/>
+                <a:ext cx="546625" cy="430887"/>
+              </a:xfrm>
+              <a:prstGeom prst="rect">
+                <a:avLst/>
+              </a:prstGeom>
+              <a:noFill/>
+            </p:spPr>
+            <p:txBody>
+              <a:bodyPr wrap="none" lIns="0" tIns="0" rIns="0" bIns="0" rtlCol="0">
+                <a:spAutoFit/>
+              </a:bodyPr>
+              <a:lstStyle/>
+              <a:p>
+                <a:pPr/>
+                <a14:m>
+                  <m:oMathPara xmlns:m="http://schemas.openxmlformats.org/officeDocument/2006/math">
+                    <m:oMathParaPr>
+                      <m:jc m:val="centerGroup"/>
+                    </m:oMathParaPr>
+                    <m:oMath xmlns:m="http://schemas.openxmlformats.org/officeDocument/2006/math">
+                      <m:r>
+                        <a:rPr lang="en-US" sz="2800" b="0" i="1" smtClean="0">
+                          <a:latin typeface="Cambria Math" panose="02040503050406030204" pitchFamily="18" charset="0"/>
+                        </a:rPr>
+                        <m:t>(</m:t>
+                      </m:r>
+                      <m:r>
+                        <m:rPr>
+                          <m:sty m:val="p"/>
+                        </m:rPr>
+                        <a:rPr lang="en-US" sz="2800" b="0" i="1" smtClean="0">
+                          <a:latin typeface="Cambria Math" panose="02040503050406030204" pitchFamily="18" charset="0"/>
+                        </a:rPr>
+                        <m:t>a</m:t>
+                      </m:r>
+                      <m:r>
+                        <a:rPr lang="en-US" sz="2800" b="0" i="1" smtClean="0">
+                          <a:latin typeface="Cambria Math" panose="02040503050406030204" pitchFamily="18" charset="0"/>
+                        </a:rPr>
+                        <m:t>)</m:t>
+                      </m:r>
+                    </m:oMath>
+                  </m:oMathPara>
+                </a14:m>
+                <a:endParaRPr lang="en-US" sz="2800" dirty="0"/>
+              </a:p>
+            </p:txBody>
+          </p:sp>
+        </mc:Choice>
+        <mc:Fallback>
+          <p:sp>
+            <p:nvSpPr>
+              <p:cNvPr id="2" name="TextBox 1">
+                <a:extLst>
+                  <a:ext uri="{FF2B5EF4-FFF2-40B4-BE49-F238E27FC236}">
+                    <a16:creationId xmlns:a16="http://schemas.microsoft.com/office/drawing/2014/main" id="{1BB98F22-5D62-E6B7-4108-0A58A1E1CDF2}"/>
+                  </a:ext>
+                </a:extLst>
+              </p:cNvPr>
+              <p:cNvSpPr txBox="1">
+                <a:spLocks noRot="1" noChangeAspect="1" noMove="1" noResize="1" noEditPoints="1" noAdjustHandles="1" noChangeArrowheads="1" noChangeShapeType="1" noTextEdit="1"/>
+              </p:cNvSpPr>
+              <p:nvPr/>
+            </p:nvSpPr>
+            <p:spPr>
+              <a:xfrm>
+                <a:off x="804885" y="458290"/>
+                <a:ext cx="546625" cy="430887"/>
               </a:xfrm>
               <a:prstGeom prst="rect">
                 <a:avLst/>
@@ -4840,7 +4777,7 @@
               <a:blipFill>
                 <a:blip r:embed="rId7"/>
                 <a:stretch>
-                  <a:fillRect b="-8000"/>
+                  <a:fillRect/>
                 </a:stretch>
               </a:blipFill>
             </p:spPr>
@@ -4939,8 +4876,8 @@
           </a:p>
         </p:txBody>
       </p:sp>
-      <mc:AlternateContent xmlns:mc="http://schemas.openxmlformats.org/markup-compatibility/2006" xmlns:a14="http://schemas.microsoft.com/office/drawing/2010/main">
-        <mc:Choice Requires="a14">
+      <mc:AlternateContent xmlns:mc="http://schemas.openxmlformats.org/markup-compatibility/2006">
+        <mc:Choice xmlns:a14="http://schemas.microsoft.com/office/drawing/2010/main" Requires="a14">
           <p:sp>
             <p:nvSpPr>
               <p:cNvPr id="5" name="TextBox 4">
@@ -4955,7 +4892,7 @@
             </p:nvSpPr>
             <p:spPr>
               <a:xfrm>
-                <a:off x="4731597" y="5783252"/>
+                <a:off x="4710233" y="5873561"/>
                 <a:ext cx="1029128" cy="430887"/>
               </a:xfrm>
               <a:prstGeom prst="rect">
@@ -5020,7 +4957,7 @@
             </p:txBody>
           </p:sp>
         </mc:Choice>
-        <mc:Fallback xmlns="">
+        <mc:Fallback>
           <p:sp>
             <p:nvSpPr>
               <p:cNvPr id="5" name="TextBox 4">
@@ -5037,7 +4974,7 @@
             </p:nvSpPr>
             <p:spPr>
               <a:xfrm>
-                <a:off x="4731597" y="5783252"/>
+                <a:off x="4710233" y="5873561"/>
                 <a:ext cx="1029128" cy="430887"/>
               </a:xfrm>
               <a:prstGeom prst="rect">
@@ -6156,8 +6093,8 @@
           </a:fontRef>
         </p:style>
       </p:cxnSp>
-      <mc:AlternateContent xmlns:mc="http://schemas.openxmlformats.org/markup-compatibility/2006" xmlns:a14="http://schemas.microsoft.com/office/drawing/2010/main">
-        <mc:Choice Requires="a14">
+      <mc:AlternateContent xmlns:mc="http://schemas.openxmlformats.org/markup-compatibility/2006">
+        <mc:Choice xmlns:a14="http://schemas.microsoft.com/office/drawing/2010/main" Requires="a14">
           <p:sp>
             <p:nvSpPr>
               <p:cNvPr id="46" name="TextBox 45">
@@ -6172,7 +6109,7 @@
             </p:nvSpPr>
             <p:spPr>
               <a:xfrm>
-                <a:off x="4418177" y="5211616"/>
+                <a:off x="4221623" y="5563311"/>
                 <a:ext cx="1384418" cy="307777"/>
               </a:xfrm>
               <a:prstGeom prst="rect">
@@ -6250,7 +6187,7 @@
             </p:txBody>
           </p:sp>
         </mc:Choice>
-        <mc:Fallback xmlns="">
+        <mc:Fallback>
           <p:sp>
             <p:nvSpPr>
               <p:cNvPr id="46" name="TextBox 45">
@@ -6267,7 +6204,7 @@
             </p:nvSpPr>
             <p:spPr>
               <a:xfrm>
-                <a:off x="4418177" y="5211616"/>
+                <a:off x="4221623" y="5563311"/>
                 <a:ext cx="1384418" cy="307777"/>
               </a:xfrm>
               <a:prstGeom prst="rect">
@@ -6373,14 +6310,14 @@
           </a:p>
         </p:txBody>
       </p:sp>
-      <mc:AlternateContent xmlns:mc="http://schemas.openxmlformats.org/markup-compatibility/2006" xmlns:a14="http://schemas.microsoft.com/office/drawing/2010/main">
-        <mc:Choice Requires="a14">
+      <mc:AlternateContent xmlns:mc="http://schemas.openxmlformats.org/markup-compatibility/2006">
+        <mc:Choice xmlns:a14="http://schemas.microsoft.com/office/drawing/2010/main" Requires="a14">
           <p:sp>
             <p:nvSpPr>
-              <p:cNvPr id="49" name="TextBox 48">
+              <p:cNvPr id="2" name="TextBox 1">
                 <a:extLst>
                   <a:ext uri="{FF2B5EF4-FFF2-40B4-BE49-F238E27FC236}">
-                    <a16:creationId xmlns:a16="http://schemas.microsoft.com/office/drawing/2014/main" id="{8DB471EF-92D5-AC44-A145-4F7C10D78AD5}"/>
+                    <a16:creationId xmlns:a16="http://schemas.microsoft.com/office/drawing/2014/main" id="{445912D0-66B3-CCDE-63F8-308E1E3A5D4C}"/>
                   </a:ext>
                 </a:extLst>
               </p:cNvPr>
@@ -6389,8 +6326,8 @@
             </p:nvSpPr>
             <p:spPr>
               <a:xfrm>
-                <a:off x="1418601" y="91427"/>
-                <a:ext cx="7218323" cy="430887"/>
+                <a:off x="804885" y="458290"/>
+                <a:ext cx="569067" cy="430887"/>
               </a:xfrm>
               <a:prstGeom prst="rect">
                 <a:avLst/>
@@ -6411,19 +6348,10 @@
                     </m:oMathParaPr>
                     <m:oMath xmlns:m="http://schemas.openxmlformats.org/officeDocument/2006/math">
                       <m:r>
-                        <m:rPr>
-                          <m:sty m:val="p"/>
-                        </m:rPr>
                         <a:rPr lang="en-US" sz="2800" b="0" i="1" smtClean="0">
                           <a:latin typeface="Cambria Math" panose="02040503050406030204" pitchFamily="18" charset="0"/>
                         </a:rPr>
-                        <m:t>Carreau</m:t>
-                      </m:r>
-                      <m:r>
-                        <a:rPr lang="en-US" sz="2800" b="0" i="1" smtClean="0">
-                          <a:latin typeface="Cambria Math" panose="02040503050406030204" pitchFamily="18" charset="0"/>
-                        </a:rPr>
-                        <m:t> </m:t>
+                        <m:t>(</m:t>
                       </m:r>
                       <m:r>
                         <m:rPr>
@@ -6432,67 +6360,13 @@
                         <a:rPr lang="en-US" sz="2800" b="0" i="1" smtClean="0">
                           <a:latin typeface="Cambria Math" panose="02040503050406030204" pitchFamily="18" charset="0"/>
                         </a:rPr>
-                        <m:t>Rheology</m:t>
+                        <m:t>b</m:t>
                       </m:r>
                       <m:r>
                         <a:rPr lang="en-US" sz="2800" b="0" i="1" smtClean="0">
                           <a:latin typeface="Cambria Math" panose="02040503050406030204" pitchFamily="18" charset="0"/>
                         </a:rPr>
-                        <m:t> </m:t>
-                      </m:r>
-                      <m:r>
-                        <m:rPr>
-                          <m:sty m:val="p"/>
-                        </m:rPr>
-                        <a:rPr lang="en-US" sz="2800" b="0" i="1" smtClean="0">
-                          <a:latin typeface="Cambria Math" panose="02040503050406030204" pitchFamily="18" charset="0"/>
-                        </a:rPr>
-                        <m:t>for</m:t>
-                      </m:r>
-                      <m:r>
-                        <a:rPr lang="en-US" sz="2800" b="0" i="1" smtClean="0">
-                          <a:latin typeface="Cambria Math" panose="02040503050406030204" pitchFamily="18" charset="0"/>
-                        </a:rPr>
-                        <m:t> </m:t>
-                      </m:r>
-                      <m:r>
-                        <m:rPr>
-                          <m:sty m:val="p"/>
-                        </m:rPr>
-                        <a:rPr lang="en-US" sz="2800" b="0" i="1" smtClean="0">
-                          <a:latin typeface="Cambria Math" panose="02040503050406030204" pitchFamily="18" charset="0"/>
-                        </a:rPr>
-                        <m:t>Shear</m:t>
-                      </m:r>
-                      <m:r>
-                        <a:rPr lang="en-US" sz="2800" b="0" i="1" smtClean="0">
-                          <a:latin typeface="Cambria Math" panose="02040503050406030204" pitchFamily="18" charset="0"/>
-                        </a:rPr>
-                        <m:t>−</m:t>
-                      </m:r>
-                      <m:r>
-                        <m:rPr>
-                          <m:sty m:val="p"/>
-                        </m:rPr>
-                        <a:rPr lang="en-US" sz="2800" b="0" i="1" smtClean="0">
-                          <a:latin typeface="Cambria Math" panose="02040503050406030204" pitchFamily="18" charset="0"/>
-                        </a:rPr>
-                        <m:t>Thickening</m:t>
-                      </m:r>
-                      <m:r>
-                        <a:rPr lang="en-US" sz="2800" b="0" i="1" smtClean="0">
-                          <a:latin typeface="Cambria Math" panose="02040503050406030204" pitchFamily="18" charset="0"/>
-                        </a:rPr>
-                        <m:t> </m:t>
-                      </m:r>
-                      <m:r>
-                        <m:rPr>
-                          <m:sty m:val="p"/>
-                        </m:rPr>
-                        <a:rPr lang="en-US" sz="2800" b="0" i="1" smtClean="0">
-                          <a:latin typeface="Cambria Math" panose="02040503050406030204" pitchFamily="18" charset="0"/>
-                        </a:rPr>
-                        <m:t>Fluids</m:t>
+                        <m:t>)</m:t>
                       </m:r>
                     </m:oMath>
                   </m:oMathPara>
@@ -6502,13 +6376,13 @@
             </p:txBody>
           </p:sp>
         </mc:Choice>
-        <mc:Fallback xmlns="">
+        <mc:Fallback>
           <p:sp>
             <p:nvSpPr>
-              <p:cNvPr id="49" name="TextBox 48">
+              <p:cNvPr id="2" name="TextBox 1">
                 <a:extLst>
                   <a:ext uri="{FF2B5EF4-FFF2-40B4-BE49-F238E27FC236}">
-                    <a16:creationId xmlns:a16="http://schemas.microsoft.com/office/drawing/2014/main" id="{8DB471EF-92D5-AC44-A145-4F7C10D78AD5}"/>
+                    <a16:creationId xmlns:a16="http://schemas.microsoft.com/office/drawing/2014/main" id="{445912D0-66B3-CCDE-63F8-308E1E3A5D4C}"/>
                   </a:ext>
                 </a:extLst>
               </p:cNvPr>
@@ -6519,8 +6393,8 @@
             </p:nvSpPr>
             <p:spPr>
               <a:xfrm>
-                <a:off x="1418601" y="91427"/>
-                <a:ext cx="7218323" cy="430887"/>
+                <a:off x="804885" y="458290"/>
+                <a:ext cx="569067" cy="430887"/>
               </a:xfrm>
               <a:prstGeom prst="rect">
                 <a:avLst/>

</xml_diff>